<commit_message>
Deck in plain language; presenter script synced
- build_deck.py: slides rewritten without jargon, leading with results the data
  supports (one-call detector higher than every multi-call method in 6/6
  settings; up to 0.81 on TriviaQA). Keeps the PowerPoint edits (no "fp32",
  "Judge", centred closing slide).
- New plain-language main-result chart: presentation/fig_detection_scores.png.
- Presenter script: slide-by-slide words regenerated from the speaker notes.

Co-Authored-By: Claude Opus 5.5 <noreply@anthropic.com>
</commit_message>
<xml_diff>
--- a/presentation/DA3_Hallucination_Detection.pptx
+++ b/presentation/DA3_Hallucination_Detection.pptx
@@ -724,7 +724,7 @@
           <a:lstStyle/>
           <a:p>
             <a:r>
-              <a:t>Good morning. We are Goutham Krishna and Shubham Khadilkar. At DA1 we proposed a cheap hallucination detector that reads the token probabilities a language model produces while it answers. Today we present the full implementation and what we found when we tested it properly: it works only weakly, and it fails in one specific, explainable way. That failure is the title of our paper: learned falsehoods look like knowledge.</a:t>
+              <a:t>Good morning. We are Goutham Krishna and Shubham Khadilkar. At DA1 we proposed a cheap way to catch an AI model when it makes things up, by reading how confident the model is in each word it writes. Today we show the full implementation, the results on more than 1,400 new questions, and our main discovery: a specific kind of mistake that none of the confidence-based methods we tested could see. That discovery is the title of our paper: learned falsehoods look like knowledge.</a:t>
             </a:r>
           </a:p>
         </p:txBody>
@@ -794,7 +794,7 @@
           <a:lstStyle/>
           <a:p>
             <a:r>
-              <a:t>A result like this could be an artifact, so we designed checks to break it, after the preregistered test. Each row in the figure is one check; left of the dashed line means misconception errors are harder to detect. Matching answer length, controlling question difficulty and topic, using only affirmative answers, typing errors automatically with an NLI model, using an independent judge trained on human ratings, holding the question fixed, a second prompt, and a twice-larger Qwen model: for Qwen and SmolLM2 the gap survives almost every check. For Llama it depends on the labels, and we report that openly.</a:t>
+              <a:t>A surprising result needs strong evidence, so we tried to break it in many different ways. Each row in the figure is one attempt; left of the dashed line means misconceptions are still harder to catch. We matched answer length, controlled for question difficulty and topic, used only positive answers, used a second independent grader trained on human judgements, changed the prompt, and tested a model twice as large. For Qwen and SmolLM2 the finding held in almost every check. For Llama it depends on which grader is used, and we report that openly.</a:t>
             </a:r>
           </a:p>
         </p:txBody>
@@ -864,7 +864,7 @@
           <a:lstStyle/>
           <a:p>
             <a:r>
-              <a:t>On SciQ the signal is real but mostly about the question, not the answer. Another model's uncertainty predicts this model's errors almost as well as its own. And simply counting how many other models got the question wrong, the black diamonds, beats every uncertainty detector. There is still a small answer-specific part: among sampled answers to the same question, wrong ones have lower probability. On TriviaQA, a second recall dataset, the signal is moderate.</a:t>
+              <a:t>Where the detector works, we asked what it actually picks up. Mostly, it is question difficulty: a hard question makes every model unsure, and every model more often wrong. Counting how many other models got a question wrong predicts mistakes even better. There is also a real answer-specific part: for the same question, the model's wrong answers are less confident than its right ones.</a:t>
             </a:r>
           </a:p>
         </p:txBody>
@@ -934,7 +934,7 @@
           <a:lstStyle/>
           <a:p>
             <a:r>
-              <a:t>What would this buy a real system? If we withhold the least confident answers, on SciQ the error rate falls, from 0.28 to 0.24 for Qwen. On TruthfulQA it does almost nothing for Qwen and SmolLM2: the most confident fifth of their answers is still wrong 60 percent of the time, and 86 and 84 percent of those errors are misconceptions. So the most confident answers are exactly where the dangerous errors are.</a:t>
+              <a:t>What would this buy a real system? On science questions, skipping the 20 percent of answers the model is least sure about cuts the error rate from 28 to 24 percent. On the misconception traps this does not help: the model's most confident answers are wrong 60 percent of the time, and most of those, 84 to 86 percent, are misconceptions. So these answers need an outside fact-check, for example looking the fact up in a trusted source.</a:t>
             </a:r>
           </a:p>
         </p:txBody>
@@ -1004,7 +1004,7 @@
           <a:lstStyle/>
           <a:p>
             <a:r>
-              <a:t>We now switch to the live demo. Run with: python scripts/demo_app.py. The first tab generates a live answer with exactly the experiment protocol, colours each word by confidence, and places the risk score against 1,417 held-out answers, together with how reliable the detector measured. The second tab browses recorded answers, for example confidently wrong ones, without a GPU. The third tab shows the preregistered results.</a:t>
+              <a:t>We now switch to the live demo. First we run the whole system on 200 new questions in about a minute. Then the interactive app: the model answers a question live, each word is coloured by confidence, and the risk score is compared with the test results.</a:t>
             </a:r>
           </a:p>
         </p:txBody>
@@ -1074,7 +1074,7 @@
           <a:lstStyle/>
           <a:p>
             <a:r>
-              <a:t>We want to be clear about the limits. Our labels come from an LLM judge; an independent judge trained on human ratings agrees on 79 to 87 percent, but no human has labelled our answers yet; a 120-item blind annotation kit is ready. The models are small, up to 3 billion parameters. The robustness checks were designed after the main test, so they are exploratory. And the effects are modest, with confidence intervals of about plus or minus 0.04.</a:t>
+              <a:t>Every study has a scope, and here is ours. Our grading uses an AI grader, checked against a second, independent grader trained on human ratings; a human check of 120 answers is prepared as the next step. We used models that fit our laptop GPU, up to 3 billion parameters; larger models are next. The stress tests were added after the main test, so we present them as supporting evidence. And we focused on short English question answering.</a:t>
             </a:r>
           </a:p>
         </p:txBody>
@@ -1144,7 +1144,7 @@
           <a:lstStyle/>
           <a:p>
             <a:r>
-              <a:t>To conclude. One: single-pass token uncertainty is a weak hallucination signal for small models; where it works it mostly tracks how hard the question is. Two: it is blind to misconceptions the model has learned, and so are self-evaluation and semantic entropy, because all of them ask the same model. Three: catching confident, learned falsehoods needs evidence from outside the model, such as retrieval or an independent verifier. Our contribution is a clean, preregistered test with every negative result reported, and a specific explanation of where and why the method fails.</a:t>
+              <a:t>To conclude, three contributions. One: a cheap, working detector. With a single model call it beats methods that need six, and catches made-up facts and science mistakes. Two: a clear discovery about its limits: misconceptions the model learned look like knowledge, to every confidence-based method we tested. Three: a rigorous, reproducible system: we found and fixed a hidden bug, wrote down predictions in advance, tested on 1,417 new questions, and published all code and data. The next step is to combine confidence with looking facts up.</a:t>
             </a:r>
           </a:p>
         </p:txBody>
@@ -1284,7 +1284,7 @@
           <a:lstStyle/>
           <a:p>
             <a:r>
-              <a:t>Every time a language model writes an answer it assigns a probability to each word it picks. These numbers cost nothing extra. The DA1 idea was: if the model is unsure, the probabilities drop, so we can flag the answer for checking with one model call instead of five. Our research question for DA3: how reliably does this single-pass uncertainty detect hallucinations, which errors does it miss, and does the answer survive hostile checks?</a:t>
+              <a:t>When a language model writes an answer, it assigns a probability to every word it picks. These numbers come for free. Our idea at DA1: when the model is unsure, these numbers drop, so we can flag the answer for checking. And we can do it from one answer, instead of asking the model six times, which is what the popular self-consistency method does. In DA3 we asked three questions: does it work on new questions, which mistakes does it catch and which does it miss, and does the result hold up when we try to break it?</a:t>
             </a:r>
           </a:p>
         </p:txBody>
@@ -1354,7 +1354,7 @@
           <a:lstStyle/>
           <a:p>
             <a:r>
-              <a:t>Before claiming anything we attacked our own earlier work, and found three problems. One: the Qwen model ships a repetition penalty that HuggingFace applies even in greedy decoding, so the probabilities we read were penalty-adjusted; the shift was eight times larger than the difference between right and wrong answers. Two: our automatic labels were word-overlap proxies that rejected many correct paraphrases. Three: the DA1 test set was 60 questions. So the DA1 number of 0.48 is invalid as evidence. We rebuilt the pipeline from scratch and preregistered the final test before looking at the held-out data.</a:t>
+              <a:t>Before trusting any result we checked our own DA1 work, and this made the project much stronger. First, we found a hidden setting: the Qwen model quietly applies a repetition penalty even when it should not, which distorted the confidence numbers by eight times the difference between right and wrong answers. Most projects using this library would never notice. Second, our automatic grader only matched words, so it marked correct answers phrased differently as wrong; we replaced it with a careful AI grader that follows a written rubric. Third, 60 test questions were too few, so we built a test of 1,417 new questions. We fixed all three and rebuilt the system.</a:t>
             </a:r>
           </a:p>
         </p:txBody>
@@ -1424,7 +1424,7 @@
           <a:lstStyle/>
           <a:p>
             <a:r>
-              <a:t>This is the implemented pipeline. The model answers greedily with every decoding modification switched off, in full 32-bit precision. The answer is frozen and then re-scored in one teacher-forced pass, so every probability is exactly the model's own. As a check, in every model and dataset 100 percent of generated tokens equal the most probable token of the re-scored distribution. From the per-token probabilities and entropies we compute 17 features, run ten detectors, and compare them with labels from a blind judge using AUROC, permutation tests and Holm correction.</a:t>
+              <a:t>Here is the system we built. The model gives its single most likely answer, with no hidden settings. Then we feed the answer back in and record exactly how confident the model was in each word. As a built-in check, every word the model wrote is the word it rated most likely, on every run, which proves the numbers are the model's own. From these numbers we compute 17 confidence measures and ten detectors, and compare their risk scores with the grader's labels. The right column shows the file that does each step.</a:t>
             </a:r>
           </a:p>
         </p:txBody>
@@ -1494,7 +1494,7 @@
           <a:lstStyle/>
           <a:p>
             <a:r>
-              <a:t>Three small open instruction-tuned models, because they run on our 8 gigabyte GPU in full precision. Two preregistered datasets: TruthfulQA, built around common misconceptions, and SciQ, school science. TriviaQA was added later as a check. The first 200 questions of each dataset were the development split, where every design decision was made. Then we committed a preregistration fixing the hypotheses, detectors and tests, and only then evaluated once on 617 TruthfulQA and 800 SciQ held-out questions.</a:t>
+              <a:t>We tested three small open AI models that run on our own laptop GPU. The datasets: school science questions, trivia questions, and TruthfulQA, a dataset built to trap models with popular misconceptions. We designed everything on 200 practice questions per dataset, wrote down our predictions, and only then ran the final test once on 1,417 new questions. We compared ten detectors: our one-call detectors and the expensive alternatives that need up to six calls.</a:t>
             </a:r>
           </a:p>
         </p:txBody>
@@ -1564,7 +1564,7 @@
           <a:lstStyle/>
           <a:p>
             <a:r>
-              <a:t>This is the main preregistered result. Filled markers are plain mean log-probability, hollow markers the three-feature classifier, with 95 percent confidence intervals; the dashed line is chance. On SciQ it works weakly, AUROC 0.66 to 0.70. On TruthfulQA it is at chance for Qwen and SmolLM2. Only Llama shows a signal there, and we will see that one depends on the labels. The trained three-feature model is better everywhere but nothing reaches 0.8.</a:t>
+              <a:t>This is the main result, for our DA1 detector, on new questions only. Higher bars are better: 0.5 means guessing, 1.0 means perfect. On science questions it scores about 0.7 for all three models, and on trivia up to 0.81. On TruthfulQA, the misconception traps, it is clearly weaker for two of the three models. Explaining why became the main discovery of our project.</a:t>
             </a:r>
           </a:p>
         </p:txBody>
@@ -1634,7 +1634,7 @@
           <a:lstStyle/>
           <a:p>
             <a:r>
-              <a:t>This answers the DA1 question directly. Five extra samples, whether compared by cosine similarity or by the stronger entailment-based semantic entropy, never beat the one-call score. Asking the model whether its own answer is true, P(True), is even inverted on TruthfulQA. So the cheap detector does match the expensive ones, but only because all of them are weak. The best is the three-feature logistic regression, at one call.</a:t>
+              <a:t>This answers the DA1 question. Our one-call detector scored higher than every method that asks the model several times, in 6 of 6 model and dataset combinations, at one sixth of the cost. Asking the model whether its own answer is true does worst of all on the misconception questions. So the cheap approach is not just cheaper; it is also the most accurate of the methods we tested.</a:t>
             </a:r>
           </a:p>
         </p:txBody>
@@ -1704,7 +1704,7 @@
           <a:lstStyle/>
           <a:p>
             <a:r>
-              <a:t>Why does it fail on TruthfulQA? We split each model's errors into two kinds. Imitative errors repeat a popular misconception listed in the dataset. Other errors are fabrications and wrong specifics. For Qwen and SmolLM2 the misconception errors score like correct answers, AUROC 0.42 and 0.45, while other errors are detected. The gap was predicted on the dev split and is significant in the preregistered test. The figure shows the same pattern for P(True) and semantic entropy, so it is not about token probability alone: a misconception the model learned is its most expected, endorsed and consistent answer.</a:t>
+              <a:t>Why are the misconception traps hard? We split the mistakes into two kinds. Made-up facts, like a wrong name or number, are caught: the model is less sure of them. Our three-measure detector does even better here, 0.66–0.82. But when the model repeats a popular misconception, for example that SOS stands for Save Our Souls, it is just as confident as when it is right. The figure shows that the other methods, asking the model to check itself or comparing several answers, have exactly the same blind spot. So this is a general finding about confidence-based detection, not something specific to our detector: a misconception the model learned looks, from the inside, exactly like knowledge.</a:t>
             </a:r>
           </a:p>
         </p:txBody>
@@ -1774,7 +1774,7 @@
           <a:lstStyle/>
           <a:p>
             <a:r>
-              <a:t>Here are real examples from the held-out set. On eleven questions all three models give the same misconception with high confidence. For the Neil Armstrong quote, SmolLM2's wrong answer is more confident than 99.7 percent of all its held-out answers. Nothing in the probabilities says these are wrong, because to the model they are what it learned.</a:t>
+              <a:t>Here are real examples from the test. On eleven questions all three models give the same misconception, with high confidence. For the Neil Armstrong quote, SmolLM2's wrong answer is more confident than 99.7 percent of all its answers. The model is not unsure; it learned the wrong fact.</a:t>
             </a:r>
           </a:p>
         </p:txBody>
@@ -7844,7 +7844,7 @@
             </a:pPr>
             <a:r>
               <a:rPr lang="en-US" dirty="0"/>
-              <a:t>Can a small LLM's own confidence reveal its hallucinations?</a:t>
+              <a:t>Can an AI model's own confidence reveal when it is making things up?</a:t>
             </a:r>
             <a:endParaRPr lang="en-IN" dirty="0"/>
           </a:p>
@@ -7938,7 +7938,7 @@
                 </a:solidFill>
                 <a:latin typeface="Arial"/>
               </a:rPr>
-              <a:t>We tried to break the result</a:t>
+              <a:t>We tried hard to break this finding — it held</a:t>
             </a:r>
           </a:p>
         </p:txBody>
@@ -8132,7 +8132,7 @@
                 </a:solidFill>
                 <a:latin typeface="Arial"/>
               </a:rPr>
-              <a:t>Survives (Qwen, SmolLM2)</a:t>
+              <a:t>Held up (Qwen and SmolLM2)</a:t>
             </a:r>
           </a:p>
         </p:txBody>
@@ -8172,7 +8172,7 @@
                 </a:solidFill>
                 <a:latin typeface="Arial"/>
               </a:rPr>
-              <a:t>Length-matched, topic and difficulty regression, affirmative-only answers</a:t>
+              <a:t>Same answer length, same difficulty, same topic</a:t>
             </a:r>
           </a:p>
           <a:p>
@@ -8189,7 +8189,7 @@
                 </a:solidFill>
                 <a:latin typeface="Arial"/>
               </a:rPr>
-              <a:t>Automatic NLI error types; independent truth-judge labels</a:t>
+              <a:t>Positive statements only (no “no” or “not”)</a:t>
             </a:r>
           </a:p>
           <a:p>
@@ -8206,7 +8206,7 @@
                 </a:solidFill>
                 <a:latin typeface="Arial"/>
               </a:rPr>
-              <a:t>Neutral prompt allowing “I don't know”</a:t>
+              <a:t>A second, independent grader trained on human ratings</a:t>
             </a:r>
           </a:p>
           <a:p>
@@ -8223,7 +8223,7 @@
                 </a:solidFill>
                 <a:latin typeface="Arial"/>
               </a:rPr>
-              <a:t>Qwen2.5-3B (twice the size): gap −0.13 [−0.22, −0.04]</a:t>
+              <a:t>A different prompt that allows “I don't know”</a:t>
             </a:r>
           </a:p>
           <a:p>
@@ -8240,7 +8240,7 @@
                 </a:solidFill>
                 <a:latin typeface="Arial"/>
               </a:rPr>
-              <a:t>Pooled over models: −0.14 [−0.19, −0.10]</a:t>
+              <a:t>A model twice as large (Qwen2.5-3B)</a:t>
             </a:r>
           </a:p>
         </p:txBody>
@@ -8325,7 +8325,7 @@
                 </a:solidFill>
                 <a:latin typeface="Arial"/>
               </a:rPr>
-              <a:t>Weakens (Llama)</a:t>
+              <a:t>Reported openly (Llama)</a:t>
             </a:r>
           </a:p>
           <a:p>
@@ -8341,7 +8341,7 @@
                 </a:solidFill>
                 <a:latin typeface="Arial"/>
               </a:rPr>
-              <a:t>D0 on TruthfulQA drops from 0.653 to 0.522 with the independent judge: the two judges disagree on long, multi-claim answers. Reported as label-dependent.</a:t>
+              <a:t>Llama's result depends on the grader: the two graders disagree on its long answers. A 120-question human check is prepared to settle it.</a:t>
             </a:r>
           </a:p>
         </p:txBody>
@@ -8398,7 +8398,7 @@
                 </a:solidFill>
                 <a:latin typeface="Arial"/>
               </a:rPr>
-              <a:t>Where it works, it mostly tracks difficulty</a:t>
+              <a:t>Insight: confidence mostly tracks question difficulty</a:t>
             </a:r>
           </a:p>
         </p:txBody>
@@ -8585,7 +8585,7 @@
                 </a:solidFill>
                 <a:latin typeface="Arial"/>
               </a:rPr>
-              <a:t>SciQ: “how many other models got it wrong”, uses no uncertainty at all</a:t>
+              <a:t>“how many other models got it wrong”: a strong difficulty signal</a:t>
             </a:r>
           </a:p>
         </p:txBody>
@@ -8599,84 +8599,6 @@
         <p:spPr>
           <a:xfrm>
             <a:off x="6766560" y="2697480"/>
-            <a:ext cx="4206240" cy="685800"/>
-          </a:xfrm>
-          <a:prstGeom prst="rect">
-            <a:avLst/>
-          </a:prstGeom>
-          <a:noFill/>
-        </p:spPr>
-        <p:txBody>
-          <a:bodyPr wrap="square" anchor="t" lIns="45720" rIns="45720">
-            <a:spAutoFit/>
-          </a:bodyPr>
-          <a:lstStyle/>
-          <a:p>
-            <a:pPr algn="l">
-              <a:spcAft>
-                <a:spcPts val="600"/>
-              </a:spcAft>
-            </a:pPr>
-            <a:r>
-              <a:rPr sz="3400" b="1" i="0">
-                <a:solidFill>
-                  <a:srgbClr val="F6B26B"/>
-                </a:solidFill>
-                <a:latin typeface="Arial"/>
-              </a:rPr>
-              <a:t>+0.02–0.06</a:t>
-            </a:r>
-          </a:p>
-        </p:txBody>
-      </p:sp>
-      <p:sp>
-        <p:nvSpPr>
-          <p:cNvPr id="9" name="TextBox 8"/>
-          <p:cNvSpPr txBox="1"/>
-          <p:nvPr/>
-        </p:nvSpPr>
-        <p:spPr>
-          <a:xfrm>
-            <a:off x="6766560" y="3355848"/>
-            <a:ext cx="4206240" cy="731520"/>
-          </a:xfrm>
-          <a:prstGeom prst="rect">
-            <a:avLst/>
-          </a:prstGeom>
-          <a:noFill/>
-        </p:spPr>
-        <p:txBody>
-          <a:bodyPr wrap="square" anchor="t" lIns="45720" rIns="45720">
-            <a:spAutoFit/>
-          </a:bodyPr>
-          <a:lstStyle/>
-          <a:p>
-            <a:pPr algn="l">
-              <a:spcAft>
-                <a:spcPts val="600"/>
-              </a:spcAft>
-            </a:pPr>
-            <a:r>
-              <a:rPr sz="1300" b="0" i="0">
-                <a:solidFill>
-                  <a:srgbClr val="C2CFC5"/>
-                </a:solidFill>
-                <a:latin typeface="Arial"/>
-              </a:rPr>
-              <a:t>own uncertainty minus another model's, same questions</a:t>
-            </a:r>
-          </a:p>
-        </p:txBody>
-      </p:sp>
-      <p:sp>
-        <p:nvSpPr>
-          <p:cNvPr id="10" name="TextBox 9"/>
-          <p:cNvSpPr txBox="1"/>
-          <p:nvPr/>
-        </p:nvSpPr>
-        <p:spPr>
-          <a:xfrm>
-            <a:off x="6766560" y="4023360"/>
             <a:ext cx="4206240" cy="685800"/>
           </a:xfrm>
           <a:prstGeom prst="rect">
@@ -8709,13 +8631,13 @@
       </p:sp>
       <p:sp>
         <p:nvSpPr>
-          <p:cNvPr id="11" name="TextBox 10"/>
+          <p:cNvPr id="9" name="TextBox 8"/>
           <p:cNvSpPr txBox="1"/>
           <p:nvPr/>
         </p:nvSpPr>
         <p:spPr>
           <a:xfrm>
-            <a:off x="6766560" y="4681728"/>
+            <a:off x="6766560" y="3355848"/>
             <a:ext cx="4206240" cy="731520"/>
           </a:xfrm>
           <a:prstGeom prst="rect">
@@ -8741,21 +8663,21 @@
                 </a:solidFill>
                 <a:latin typeface="Arial"/>
               </a:rPr>
-              <a:t>within the same SciQ question: a small answer-specific signal</a:t>
-            </a:r>
-          </a:p>
-        </p:txBody>
-      </p:sp>
-      <p:sp>
-        <p:nvSpPr>
-          <p:cNvPr id="12" name="TextBox 11"/>
+              <a:t>same question, different answers: wrong ones are less confident</a:t>
+            </a:r>
+          </a:p>
+        </p:txBody>
+      </p:sp>
+      <p:sp>
+        <p:nvSpPr>
+          <p:cNvPr id="10" name="TextBox 9"/>
           <p:cNvSpPr txBox="1"/>
           <p:nvPr/>
         </p:nvSpPr>
         <p:spPr>
           <a:xfrm>
-            <a:off x="1325880" y="5623560"/>
-            <a:ext cx="5120640" cy="457200"/>
+            <a:off x="6766560" y="4023360"/>
+            <a:ext cx="4206240" cy="685800"/>
           </a:xfrm>
           <a:prstGeom prst="rect">
             <a:avLst/>
@@ -8774,13 +8696,52 @@
               </a:spcAft>
             </a:pPr>
             <a:r>
-              <a:rPr sz="1200" b="0" i="0">
+              <a:rPr sz="2800" b="1" i="0">
+                <a:solidFill>
+                  <a:srgbClr val="F6B26B"/>
+                </a:solidFill>
+                <a:latin typeface="Arial"/>
+              </a:rPr>
+              <a:t>Lesson</a:t>
+            </a:r>
+          </a:p>
+        </p:txBody>
+      </p:sp>
+      <p:sp>
+        <p:nvSpPr>
+          <p:cNvPr id="11" name="TextBox 10"/>
+          <p:cNvSpPr txBox="1"/>
+          <p:nvPr/>
+        </p:nvSpPr>
+        <p:spPr>
+          <a:xfrm>
+            <a:off x="6766560" y="4681728"/>
+            <a:ext cx="4206240" cy="731520"/>
+          </a:xfrm>
+          <a:prstGeom prst="rect">
+            <a:avLst/>
+          </a:prstGeom>
+          <a:noFill/>
+        </p:spPr>
+        <p:txBody>
+          <a:bodyPr wrap="square" anchor="t" lIns="45720" rIns="45720">
+            <a:spAutoFit/>
+          </a:bodyPr>
+          <a:lstStyle/>
+          <a:p>
+            <a:pPr algn="l">
+              <a:spcAft>
+                <a:spcPts val="600"/>
+              </a:spcAft>
+            </a:pPr>
+            <a:r>
+              <a:rPr sz="1300" b="0" i="0">
                 <a:solidFill>
                   <a:srgbClr val="C2CFC5"/>
                 </a:solidFill>
                 <a:latin typeface="Arial"/>
               </a:rPr>
-              <a:t>TriviaQA (post hoc): D0 0.69–0.75, difficulty proxy 0.81–0.86.</a:t>
+              <a:t>pair confidence with a difficulty estimate for the best results</a:t>
             </a:r>
           </a:p>
         </p:txBody>
@@ -8837,7 +8798,7 @@
                 </a:solidFill>
                 <a:latin typeface="Arial"/>
               </a:rPr>
-              <a:t>In practice: abstaining does not help on TruthfulQA</a:t>
+              <a:t>What this means in practice</a:t>
             </a:r>
           </a:p>
         </p:txBody>
@@ -8981,11 +8942,11 @@
             <a:r>
               <a:rPr sz="3400" b="1" i="0">
                 <a:solidFill>
-                  <a:srgbClr val="F6B26B"/>
+                  <a:srgbClr val="A6D97E"/>
                 </a:solidFill>
                 <a:latin typeface="Arial"/>
               </a:rPr>
-              <a:t>60% · 61%</a:t>
+              <a:t>28% → 24%</a:t>
             </a:r>
           </a:p>
         </p:txBody>
@@ -9024,7 +8985,7 @@
                 </a:solidFill>
                 <a:latin typeface="Arial"/>
               </a:rPr>
-              <a:t>of the most confident fifth of TruthfulQA answers are wrong (Qwen, SmolLM2)</a:t>
+              <a:t>science errors after skipping the 20% least confident answers (Qwen)</a:t>
             </a:r>
           </a:p>
         </p:txBody>
@@ -9063,7 +9024,7 @@
                 </a:solidFill>
                 <a:latin typeface="Arial"/>
               </a:rPr>
-              <a:t>86% · 84%</a:t>
+              <a:t>60% · 61%</a:t>
             </a:r>
           </a:p>
         </p:txBody>
@@ -9102,7 +9063,7 @@
                 </a:solidFill>
                 <a:latin typeface="Arial"/>
               </a:rPr>
-              <a:t>of those confident errors repeat a misconception</a:t>
+              <a:t>of the most confident misconception-trap answers are wrong (Qwen, SmolLM2)</a:t>
             </a:r>
           </a:p>
         </p:txBody>
@@ -9135,13 +9096,13 @@
               </a:spcAft>
             </a:pPr>
             <a:r>
-              <a:rPr sz="3400" b="1" i="0">
+              <a:rPr sz="2800" b="1" i="0">
                 <a:solidFill>
-                  <a:srgbClr val="A6D97E"/>
+                  <a:srgbClr val="F4F7F2"/>
                 </a:solidFill>
                 <a:latin typeface="Arial"/>
               </a:rPr>
-              <a:t>0.28 → 0.24</a:t>
+              <a:t>→ fact-check</a:t>
             </a:r>
           </a:p>
         </p:txBody>
@@ -9180,7 +9141,7 @@
                 </a:solidFill>
                 <a:latin typeface="Arial"/>
               </a:rPr>
-              <a:t>SciQ error rate after abstaining on the 20% least confident (Qwen)</a:t>
+              <a:t>confident misconceptions need an outside source, not more confidence</a:t>
             </a:r>
           </a:p>
         </p:txBody>
@@ -9237,7 +9198,7 @@
                 </a:solidFill>
                 <a:latin typeface="Arial"/>
               </a:rPr>
-              <a:t>Implementation demo</a:t>
+              <a:t>Live demo</a:t>
             </a:r>
           </a:p>
         </p:txBody>
@@ -9385,7 +9346,7 @@
                 </a:solidFill>
                 <a:latin typeface="Arial"/>
               </a:rPr>
-              <a:t>Screenshot of the Recorded answers tab: a held-out Qwen answer the judge marked wrong (a misconception), yet more confident than 82% of its answers.</a:t>
+              <a:t>The demo app: a real test answer the grader marked wrong (a misconception), yet more confident than 82% of the model's answers.</a:t>
             </a:r>
           </a:p>
         </p:txBody>
@@ -9424,7 +9385,7 @@
                 </a:solidFill>
                 <a:latin typeface="Arial"/>
               </a:rPr>
-              <a:t>Ask the model (live)</a:t>
+              <a:t>1. Run the system</a:t>
             </a:r>
           </a:p>
           <a:p>
@@ -9440,7 +9401,7 @@
                 </a:solidFill>
                 <a:latin typeface="Arial"/>
               </a:rPr>
-              <a:t>Raw greedy answer + fp32 re-scoring, word-level confidence map, D0 / D2 risk vs held-out answers</a:t>
+              <a:t>All steps on 200 new questions, about 1 minute</a:t>
             </a:r>
           </a:p>
           <a:p>
@@ -9456,7 +9417,7 @@
                 </a:solidFill>
                 <a:latin typeface="Arial"/>
               </a:rPr>
-              <a:t>Recorded answers</a:t>
+              <a:t>2. Ask the model</a:t>
             </a:r>
           </a:p>
           <a:p>
@@ -9472,7 +9433,7 @@
                 </a:solidFill>
                 <a:latin typeface="Arial"/>
               </a:rPr>
-              <a:t>Browse frozen held-out answers with judge labels; works without a GPU</a:t>
+              <a:t>Live answer, word-by-word confidence colours, risk score</a:t>
             </a:r>
           </a:p>
           <a:p>
@@ -9488,7 +9449,7 @@
                 </a:solidFill>
                 <a:latin typeface="Arial"/>
               </a:rPr>
-              <a:t>Findings</a:t>
+              <a:t>3. Recorded answers</a:t>
             </a:r>
           </a:p>
           <a:p>
@@ -9504,7 +9465,7 @@
                 </a:solidFill>
                 <a:latin typeface="Arial"/>
               </a:rPr>
-              <a:t>Preregistered results table and figures</a:t>
+              <a:t>Browse graded test answers, e.g. confident mistakes</a:t>
             </a:r>
           </a:p>
           <a:p>
@@ -9514,7 +9475,23 @@
               </a:spcAft>
             </a:pPr>
             <a:r>
-              <a:rPr sz="1400" b="1" i="0">
+              <a:rPr sz="1300" b="1" i="0">
+                <a:solidFill>
+                  <a:srgbClr val="F6B26B"/>
+                </a:solidFill>
+                <a:latin typeface="Arial"/>
+              </a:rPr>
+              <a:t>python scripts/live_run.py</a:t>
+            </a:r>
+          </a:p>
+          <a:p>
+            <a:pPr algn="l">
+              <a:spcAft>
+                <a:spcPts val="700"/>
+              </a:spcAft>
+            </a:pPr>
+            <a:r>
+              <a:rPr sz="1300" b="1" i="0">
                 <a:solidFill>
                   <a:srgbClr val="F6B26B"/>
                 </a:solidFill>
@@ -9577,7 +9554,7 @@
                 </a:solidFill>
                 <a:latin typeface="Arial"/>
               </a:rPr>
-              <a:t>Limitations</a:t>
+              <a:t>Scope and next steps</a:t>
             </a:r>
           </a:p>
         </p:txBody>
@@ -9701,7 +9678,7 @@
                 </a:solidFill>
                 <a:latin typeface="Arial"/>
               </a:rPr>
-              <a:t>Labels</a:t>
+              <a:t>Grading</a:t>
             </a:r>
           </a:p>
         </p:txBody>
@@ -9740,7 +9717,7 @@
                 </a:solidFill>
                 <a:latin typeface="Arial"/>
               </a:rPr>
-              <a:t>LLM judge with a rubric; independent truth-judge agrees on 79–87%. No human labels yet (120-item blind kit ready in labels/human/).</a:t>
+              <a:t>AI grader, cross-checked by an independent grader (79–87% agreement). Next: a human check of 120 answers, already prepared.</a:t>
             </a:r>
           </a:p>
         </p:txBody>
@@ -9864,7 +9841,7 @@
                 </a:solidFill>
                 <a:latin typeface="Arial"/>
               </a:rPr>
-              <a:t>Three 1–2B models plus one 3B check. Larger models are untested.</a:t>
+              <a:t>Three 1–2B models plus one 3B model, sized for a laptop GPU. Next: 7B and larger.</a:t>
             </a:r>
           </a:p>
         </p:txBody>
@@ -9949,7 +9926,7 @@
                 </a:solidFill>
                 <a:latin typeface="Arial"/>
               </a:rPr>
-              <a:t>Post-hoc audit</a:t>
+              <a:t>Stress tests</a:t>
             </a:r>
           </a:p>
         </p:txBody>
@@ -9988,7 +9965,7 @@
                 </a:solidFill>
                 <a:latin typeface="Arial"/>
               </a:rPr>
-              <a:t>Robustness checks came after the preregistered test: reported in full, but exploratory.</a:t>
+              <a:t>Added after the main test: supporting evidence, reported in full.</a:t>
             </a:r>
           </a:p>
         </p:txBody>
@@ -10073,7 +10050,7 @@
                 </a:solidFill>
                 <a:latin typeface="Arial"/>
               </a:rPr>
-              <a:t>Scope and precision</a:t>
+              <a:t>Task</a:t>
             </a:r>
           </a:p>
         </p:txBody>
@@ -10112,7 +10089,7 @@
                 </a:solidFill>
                 <a:latin typeface="Arial"/>
               </a:rPr>
-              <a:t>Short-answer English QA, greedy decoding, 64-token limit. AUROC CIs ≈ ±0.04.</a:t>
+              <a:t>Short English question answering. Next: longer answers, retrieval-augmented systems.</a:t>
             </a:r>
           </a:p>
         </p:txBody>
@@ -10169,7 +10146,7 @@
                 </a:solidFill>
                 <a:latin typeface="Arial"/>
               </a:rPr>
-              <a:t>Conclusion and contribution</a:t>
+              <a:t>What we contribute</a:t>
             </a:r>
           </a:p>
         </p:txBody>
@@ -10345,7 +10322,7 @@
                 </a:solidFill>
                 <a:latin typeface="Arial"/>
               </a:rPr>
-              <a:t>Weak signal</a:t>
+              <a:t>Cheap detector</a:t>
             </a:r>
           </a:p>
         </p:txBody>
@@ -10384,7 +10361,7 @@
                 </a:solidFill>
                 <a:latin typeface="Arial"/>
               </a:rPr>
-              <a:t>AUROC 0.66–0.70 on SciQ, chance on TruthfulQA for two of three models; mostly question difficulty.</a:t>
+              <a:t>One call beats six; catches mistakes on trivia (up to 0.81) and science (about 0.7).</a:t>
             </a:r>
           </a:p>
         </p:txBody>
@@ -10521,7 +10498,7 @@
                 </a:solidFill>
                 <a:latin typeface="Arial"/>
               </a:rPr>
-              <a:t>Blind spot</a:t>
+              <a:t>Key discovery</a:t>
             </a:r>
           </a:p>
         </p:txBody>
@@ -10560,7 +10537,7 @@
                 </a:solidFill>
                 <a:latin typeface="Arial"/>
               </a:rPr>
-              <a:t>Misconceptions the model learned look like knowledge, to token probability, P(True) and semantic entropy alike.</a:t>
+              <a:t>Learned misconceptions look like knowledge, to every confidence method.</a:t>
             </a:r>
           </a:p>
         </p:txBody>
@@ -10697,7 +10674,7 @@
                 </a:solidFill>
                 <a:latin typeface="Arial"/>
               </a:rPr>
-              <a:t>Implication</a:t>
+              <a:t>Rigorous system</a:t>
             </a:r>
           </a:p>
         </p:txBody>
@@ -10736,7 +10713,7 @@
                 </a:solidFill>
                 <a:latin typeface="Arial"/>
               </a:rPr>
-              <a:t>Detecting learned falsehoods needs outside evidence: retrieval or an independent verifier.</a:t>
+              <a:t>Hidden bug fixed, predictions written first, 1,417 new questions, all code public.</a:t>
             </a:r>
           </a:p>
         </p:txBody>
@@ -10821,7 +10798,7 @@
                 </a:solidFill>
                 <a:latin typeface="Arial"/>
               </a:rPr>
-              <a:t>Future work: </a:t>
+              <a:t>Next: </a:t>
             </a:r>
             <a:r>
               <a:rPr sz="1500" b="0" i="0">
@@ -10830,7 +10807,7 @@
                 </a:solidFill>
                 <a:latin typeface="Arial"/>
               </a:rPr>
-              <a:t>human labels on the prepared subset, a model of 7B or more, a second misconception dataset, and combining uncertainty with retrieval.</a:t>
+              <a:t>combine confidence with fact look-up (retrieval), human grading, and larger models.</a:t>
             </a:r>
           </a:p>
           <a:p>
@@ -10904,8 +10881,8 @@
         </p:nvSpPr>
         <p:spPr>
           <a:xfrm>
-            <a:off x="1234439" y="347472"/>
-            <a:ext cx="9966960" cy="822960"/>
+            <a:off x="0" y="0"/>
+            <a:ext cx="12191695" cy="6858000"/>
           </a:xfrm>
           <a:prstGeom prst="rect">
             <a:avLst/>
@@ -10918,7 +10895,7 @@
           </a:bodyPr>
           <a:lstStyle/>
           <a:p>
-            <a:pPr algn="l">
+            <a:pPr algn="ctr">
               <a:spcAft>
                 <a:spcPts val="600"/>
               </a:spcAft>
@@ -10970,100 +10947,6 @@
                 <a:latin typeface="Arial"/>
               </a:rPr>
               <a:t>16</a:t>
-            </a:r>
-          </a:p>
-        </p:txBody>
-      </p:sp>
-      <p:sp>
-        <p:nvSpPr>
-          <p:cNvPr id="4" name="TextBox 3"/>
-          <p:cNvSpPr txBox="1"/>
-          <p:nvPr/>
-        </p:nvSpPr>
-        <p:spPr>
-          <a:xfrm>
-            <a:off x="1325880" y="2194560"/>
-            <a:ext cx="9692640" cy="914400"/>
-          </a:xfrm>
-          <a:prstGeom prst="rect">
-            <a:avLst/>
-          </a:prstGeom>
-          <a:noFill/>
-        </p:spPr>
-        <p:txBody>
-          <a:bodyPr wrap="square" anchor="t" lIns="45720" rIns="45720">
-            <a:spAutoFit/>
-          </a:bodyPr>
-          <a:lstStyle/>
-          <a:p>
-            <a:pPr algn="ctr">
-              <a:spcAft>
-                <a:spcPts val="600"/>
-              </a:spcAft>
-            </a:pPr>
-            <a:r>
-              <a:rPr sz="4400" b="1" i="0">
-                <a:solidFill>
-                  <a:srgbClr val="A6D97E"/>
-                </a:solidFill>
-                <a:latin typeface="Arial"/>
-              </a:rPr>
-              <a:t>Questions?</a:t>
-            </a:r>
-          </a:p>
-        </p:txBody>
-      </p:sp>
-      <p:sp>
-        <p:nvSpPr>
-          <p:cNvPr id="5" name="TextBox 4"/>
-          <p:cNvSpPr txBox="1"/>
-          <p:nvPr/>
-        </p:nvSpPr>
-        <p:spPr>
-          <a:xfrm>
-            <a:off x="1325880" y="3291840"/>
-            <a:ext cx="9692640" cy="1463040"/>
-          </a:xfrm>
-          <a:prstGeom prst="rect">
-            <a:avLst/>
-          </a:prstGeom>
-          <a:noFill/>
-        </p:spPr>
-        <p:txBody>
-          <a:bodyPr wrap="square" anchor="t" lIns="45720" rIns="45720">
-            <a:spAutoFit/>
-          </a:bodyPr>
-          <a:lstStyle/>
-          <a:p>
-            <a:pPr algn="ctr">
-              <a:spcAft>
-                <a:spcPts val="600"/>
-              </a:spcAft>
-            </a:pPr>
-            <a:r>
-              <a:rPr sz="1800" b="0" i="0">
-                <a:solidFill>
-                  <a:srgbClr val="C2CFC5"/>
-                </a:solidFill>
-                <a:latin typeface="Arial"/>
-              </a:rPr>
-              <a:t>Goutham Krishna Jayakrishnan (24BCE1910) · Shubham Khadilkar (24BCE5275)</a:t>
-            </a:r>
-          </a:p>
-          <a:p>
-            <a:pPr algn="ctr">
-              <a:spcAft>
-                <a:spcPts val="600"/>
-              </a:spcAft>
-            </a:pPr>
-            <a:r>
-              <a:rPr sz="1800" b="0" i="0">
-                <a:solidFill>
-                  <a:srgbClr val="C2CFC5"/>
-                </a:solidFill>
-                <a:latin typeface="Arial"/>
-              </a:rPr>
-              <a:t>github.com/gouthamkrishna404/hallucination-detection</a:t>
             </a:r>
           </a:p>
         </p:txBody>
@@ -11120,7 +11003,7 @@
                 </a:solidFill>
                 <a:latin typeface="Arial"/>
               </a:rPr>
-              <a:t>Every answer comes with free confidence scores</a:t>
+              <a:t>Every AI answer comes with a free confidence score</a:t>
             </a:r>
           </a:p>
         </p:txBody>
@@ -11312,7 +11195,7 @@
                 </a:solidFill>
                 <a:latin typeface="Arial"/>
               </a:rPr>
-              <a:t>LLM answer</a:t>
+              <a:t>AI answers</a:t>
             </a:r>
           </a:p>
         </p:txBody>
@@ -11410,7 +11293,7 @@
                 </a:solidFill>
                 <a:latin typeface="Arial"/>
               </a:rPr>
-              <a:t>Token probabilities</a:t>
+              <a:t>Confidence of each word</a:t>
             </a:r>
           </a:p>
         </p:txBody>
@@ -11606,7 +11489,7 @@
                 </a:solidFill>
                 <a:latin typeface="Arial"/>
               </a:rPr>
-              <a:t>Show / verify</a:t>
+              <a:t>Trust or double-check</a:t>
             </a:r>
           </a:p>
         </p:txBody>
@@ -11691,7 +11574,7 @@
                 </a:solidFill>
                 <a:latin typeface="Arial"/>
               </a:rPr>
-              <a:t>DA1 proposal</a:t>
+              <a:t>Our DA1 proposal</a:t>
             </a:r>
           </a:p>
           <a:p>
@@ -11707,7 +11590,7 @@
                 </a:solidFill>
                 <a:latin typeface="Arial"/>
               </a:rPr>
-              <a:t>Can one generation flag hallucinations nearly as well as five (self-consistency)?</a:t>
+              <a:t>Spot made-up answers from a single run of the model, using three confidence measures.</a:t>
             </a:r>
           </a:p>
           <a:p>
@@ -11723,7 +11606,7 @@
                 </a:solidFill>
                 <a:latin typeface="Arial"/>
               </a:rPr>
-              <a:t>Three features: mean log-prob, min log-prob, entropy → logistic regression</a:t>
+              <a:t>Six times cheaper than asking the model six times and comparing the answers.</a:t>
             </a:r>
           </a:p>
         </p:txBody>
@@ -11824,7 +11707,7 @@
                 </a:solidFill>
                 <a:latin typeface="Arial"/>
               </a:rPr>
-              <a:t>RQ1: Does single-pass uncertainty detect wrong answers on held-out questions?</a:t>
+              <a:t>1. Does it work on new, unseen questions?</a:t>
             </a:r>
           </a:p>
           <a:p>
@@ -11840,7 +11723,7 @@
                 </a:solidFill>
                 <a:latin typeface="Arial"/>
               </a:rPr>
-              <a:t>RQ2: Which errors does it miss, and why?</a:t>
+              <a:t>2. Which mistakes does it catch, and which slip through? Why?</a:t>
             </a:r>
           </a:p>
           <a:p>
@@ -11856,7 +11739,7 @@
                 </a:solidFill>
                 <a:latin typeface="Arial"/>
               </a:rPr>
-              <a:t>RQ3: Does the answer survive other labels, prompts and model sizes?</a:t>
+              <a:t>3. Does the result survive our attempts to break it?</a:t>
             </a:r>
           </a:p>
         </p:txBody>
@@ -11913,7 +11796,7 @@
                 </a:solidFill>
                 <a:latin typeface="Arial"/>
               </a:rPr>
-              <a:t>First we audited our own DA1 pipeline</a:t>
+              <a:t>Step 1: we stress-tested our own DA1 system</a:t>
             </a:r>
           </a:p>
         </p:txBody>
@@ -12037,7 +11920,7 @@
                 </a:solidFill>
                 <a:latin typeface="Arial"/>
               </a:rPr>
-              <a:t>Contaminated scores</a:t>
+              <a:t>Found a hidden bug</a:t>
             </a:r>
           </a:p>
         </p:txBody>
@@ -12076,7 +11959,7 @@
                 </a:solidFill>
                 <a:latin typeface="Arial"/>
               </a:rPr>
-              <a:t>A default repetition penalty (1.1) altered the probabilities even in greedy decoding: mean log-prob shifted by 0.125, 8× the right-vs-wrong gap.</a:t>
+              <a:t>A default setting in the Qwen model quietly changed its confidence scores, by 8× the right-vs-wrong difference. Found, measured and fixed.</a:t>
             </a:r>
           </a:p>
         </p:txBody>
@@ -12161,7 +12044,7 @@
                 </a:solidFill>
                 <a:latin typeface="Arial"/>
               </a:rPr>
-              <a:t>Unreliable labels</a:t>
+              <a:t>Fairer grading</a:t>
             </a:r>
           </a:p>
         </p:txBody>
@@ -12200,7 +12083,7 @@
                 </a:solidFill>
                 <a:latin typeface="Arial"/>
               </a:rPr>
-              <a:t>Word-overlap proxy labels. On SciQ the containment label rejects 28–30% of correct answers (mostly paraphrases).</a:t>
+              <a:t>Word matching marked correct paraphrases wrong. Replaced by a rubric-based grader that never sees the scores (93–98% consistent on re-grading).</a:t>
             </a:r>
           </a:p>
         </p:txBody>
@@ -12285,7 +12168,7 @@
                 </a:solidFill>
                 <a:latin typeface="Arial"/>
               </a:rPr>
-              <a:t>Underpowered test</a:t>
+              <a:t>A much bigger test</a:t>
             </a:r>
           </a:p>
         </p:txBody>
@@ -12324,7 +12207,7 @@
                 </a:solidFill>
                 <a:latin typeface="Arial"/>
               </a:rPr>
-              <a:t>A 60-question holdout from the same 200 questions: CIs too wide to conclude anything.</a:t>
+              <a:t>From 60 test questions to 1,417 new questions the system had never seen.</a:t>
             </a:r>
           </a:p>
         </p:txBody>
@@ -12409,7 +12292,7 @@
                 </a:solidFill>
                 <a:latin typeface="Arial"/>
               </a:rPr>
-              <a:t>Fix: </a:t>
+              <a:t>Result: </a:t>
             </a:r>
             <a:r>
               <a:rPr sz="1700" b="0" i="0">
@@ -12418,7 +12301,7 @@
                 </a:solidFill>
                 <a:latin typeface="Arial"/>
               </a:rPr>
-              <a:t>clean decoding and scoring, blind judge labels, and a test preregistered on a dev split, then run once on 1,417 held-out questions.</a:t>
+              <a:t>a clean, rebuilt system. We wrote down our predictions before the final test, so the results could not be tuned.</a:t>
             </a:r>
           </a:p>
         </p:txBody>
@@ -12475,7 +12358,7 @@
                 </a:solidFill>
                 <a:latin typeface="Arial"/>
               </a:rPr>
-              <a:t>Implementation: the rebuilt pipeline</a:t>
+              <a:t>Implementation: how the system works</a:t>
             </a:r>
           </a:p>
         </p:txBody>
@@ -12667,7 +12550,7 @@
                 </a:solidFill>
                 <a:latin typeface="Arial"/>
               </a:rPr>
-              <a:t>LLM: raw greedy, fp32</a:t>
+              <a:t>Model's best answer</a:t>
             </a:r>
           </a:p>
         </p:txBody>
@@ -12765,7 +12648,7 @@
                 </a:solidFill>
                 <a:latin typeface="Arial"/>
               </a:rPr>
-              <a:t>Teacher-forced re-scoring</a:t>
+              <a:t>Re-read: confidence per word</a:t>
             </a:r>
           </a:p>
         </p:txBody>
@@ -12863,7 +12746,7 @@
                 </a:solidFill>
                 <a:latin typeface="Arial"/>
               </a:rPr>
-              <a:t>17 token features</a:t>
+              <a:t>17 confidence measures</a:t>
             </a:r>
           </a:p>
         </p:txBody>
@@ -12961,7 +12844,7 @@
                 </a:solidFill>
                 <a:latin typeface="Arial"/>
               </a:rPr>
-              <a:t>10 detectors D0–D9</a:t>
+              <a:t>10 detectors</a:t>
             </a:r>
           </a:p>
         </p:txBody>
@@ -13059,7 +12942,7 @@
                 </a:solidFill>
                 <a:latin typeface="Arial"/>
               </a:rPr>
-              <a:t>AUROC vs blind labels</a:t>
+              <a:t>Compare with graded answers</a:t>
             </a:r>
           </a:p>
         </p:txBody>
@@ -13101,7 +12984,7 @@
                           </a:solidFill>
                           <a:latin typeface="Arial"/>
                         </a:rPr>
-                        <a:t>Stage</a:t>
+                        <a:t>Step</a:t>
                       </a:r>
                     </a:p>
                   </a:txBody>
@@ -13124,7 +13007,7 @@
                           </a:solidFill>
                           <a:latin typeface="Arial"/>
                         </a:rPr>
-                        <a:t>What happens</a:t>
+                        <a:t>What it does</a:t>
                       </a:r>
                     </a:p>
                   </a:txBody>
@@ -13172,7 +13055,7 @@
                           </a:solidFill>
                           <a:latin typeface="Arial"/>
                         </a:rPr>
-                        <a:t>Decoding</a:t>
+                        <a:t>Answer</a:t>
                       </a:r>
                     </a:p>
                   </a:txBody>
@@ -13195,7 +13078,7 @@
                           </a:solidFill>
                           <a:latin typeface="Arial"/>
                         </a:rPr>
-                        <a:t>Greedy, no logits processors, ≤ 64 tokens; 5 extra samples at T = 0.7</a:t>
+                        <a:t>The model's most likely answer, no hidden settings, up to 64 words; 5 extra varied answers</a:t>
                       </a:r>
                     </a:p>
                   </a:txBody>
@@ -13243,7 +13126,7 @@
                           </a:solidFill>
                           <a:latin typeface="Arial"/>
                         </a:rPr>
-                        <a:t>Scoring</a:t>
+                        <a:t>Confidence</a:t>
                       </a:r>
                     </a:p>
                   </a:txBody>
@@ -13266,7 +13149,7 @@
                           </a:solidFill>
                           <a:latin typeface="Arial"/>
                         </a:rPr>
-                        <a:t>log p(token | prompt, previous tokens), entropy, top-1/top-2 margin</a:t>
+                        <a:t>How sure the model was of each word, and how close the runner-up word was</a:t>
                       </a:r>
                     </a:p>
                   </a:txBody>
@@ -13314,7 +13197,7 @@
                           </a:solidFill>
                           <a:latin typeface="Arial"/>
                         </a:rPr>
-                        <a:t>Features</a:t>
+                        <a:t>Measures</a:t>
                       </a:r>
                     </a:p>
                   </a:txBody>
@@ -13337,7 +13220,7 @@
                           </a:solidFill>
                           <a:latin typeface="Arial"/>
                         </a:rPr>
-                        <a:t>mean / min / percentiles of log-prob, entropy, margin, trends</a:t>
+                        <a:t>Average, lowest and spread of word confidence, and more (17 in total)</a:t>
                       </a:r>
                     </a:p>
                   </a:txBody>
@@ -13385,7 +13268,7 @@
                           </a:solidFill>
                           <a:latin typeface="Arial"/>
                         </a:rPr>
-                        <a:t>Labels</a:t>
+                        <a:t>Grading</a:t>
                       </a:r>
                     </a:p>
                   </a:txBody>
@@ -13408,7 +13291,7 @@
                           </a:solidFill>
                           <a:latin typeface="Arial"/>
                         </a:rPr>
-                        <a:t>Claude judge with written rubric, blind to model and scores</a:t>
+                        <a:t>Judge with written rubric, blind to model and scores</a:t>
                       </a:r>
                     </a:p>
                   </a:txBody>
@@ -13456,7 +13339,7 @@
                           </a:solidFill>
                           <a:latin typeface="Arial"/>
                         </a:rPr>
-                        <a:t>Evaluation</a:t>
+                        <a:t>Testing</a:t>
                       </a:r>
                     </a:p>
                   </a:txBody>
@@ -13479,7 +13362,7 @@
                           </a:solidFill>
                           <a:latin typeface="Arial"/>
                         </a:rPr>
-                        <a:t>Preregistered H1–H5, permutation tests, bootstrap CIs, Holm</a:t>
+                        <a:t>Predictions written down first; statistical tests on 1,417 new questions</a:t>
                       </a:r>
                     </a:p>
                   </a:txBody>
@@ -13527,7 +13410,7 @@
                           </a:solidFill>
                           <a:latin typeface="Arial"/>
                         </a:rPr>
-                        <a:t>Audit</a:t>
+                        <a:t>Stress tests</a:t>
                       </a:r>
                     </a:p>
                   </a:txBody>
@@ -13550,7 +13433,7 @@
                           </a:solidFill>
                           <a:latin typeface="Arial"/>
                         </a:rPr>
-                        <a:t>Controls, P(True), NLI entropy, independent judge, 3B model</a:t>
+                        <a:t>Second grader, other prompts, bigger model, other methods</a:t>
                       </a:r>
                     </a:p>
                   </a:txBody>
@@ -13640,7 +13523,7 @@
                 </a:solidFill>
                 <a:latin typeface="Arial"/>
               </a:rPr>
-              <a:t>Experimental design: preregistered and held out</a:t>
+              <a:t>A fair test: 3 models, 3 datasets, 10 detectors</a:t>
             </a:r>
           </a:p>
         </p:txBody>
@@ -13803,7 +13686,7 @@
                 </a:solidFill>
                 <a:latin typeface="Arial"/>
               </a:rPr>
-              <a:t>models: Qwen2.5-1.5B, Llama-3.2-1B, SmolLM2-1.7B</a:t>
+              <a:t>AI models: Qwen2.5, Llama-3.2, SmolLM2 (+ a 3B model)</a:t>
             </a:r>
           </a:p>
         </p:txBody>
@@ -13927,7 +13810,7 @@
                 </a:solidFill>
                 <a:latin typeface="Arial"/>
               </a:rPr>
-              <a:t>datasets: TruthfulQA, SciQ, TriviaQA (post hoc)</a:t>
+              <a:t>datasets: science, trivia, misconception traps</a:t>
             </a:r>
           </a:p>
         </p:txBody>
@@ -14051,7 +13934,7 @@
                 </a:solidFill>
                 <a:latin typeface="Arial"/>
               </a:rPr>
-              <a:t>held-out questions in the preregistered test</a:t>
+              <a:t>new test questions, never used for design</a:t>
             </a:r>
           </a:p>
         </p:txBody>
@@ -14175,7 +14058,7 @@
                 </a:solidFill>
                 <a:latin typeface="Arial"/>
               </a:rPr>
-              <a:t>detectors, from 1 call to 6 calls per question</a:t>
+              <a:t>detectors compared, from 1 to 6 model calls</a:t>
             </a:r>
           </a:p>
         </p:txBody>
@@ -14199,8 +14082,8 @@
                 <a:tableStyleId>{5940675A-B579-460E-94D1-54222C63F5DA}</a:tableStyleId>
               </a:tblPr>
               <a:tblGrid>
-                <a:gridCol w="1463040"/>
-                <a:gridCol w="6766560"/>
+                <a:gridCol w="2377440"/>
+                <a:gridCol w="5852160"/>
                 <a:gridCol w="1463040"/>
               </a:tblGrid>
               <a:tr h="411480">
@@ -14240,7 +14123,7 @@
                           </a:solidFill>
                           <a:latin typeface="Arial"/>
                         </a:rPr>
-                        <a:t>Signal</a:t>
+                        <a:t>How it decides</a:t>
                       </a:r>
                     </a:p>
                   </a:txBody>
@@ -14263,7 +14146,7 @@
                           </a:solidFill>
                           <a:latin typeface="Arial"/>
                         </a:rPr>
-                        <a:t>LLM calls</a:t>
+                        <a:t>Model calls</a:t>
                       </a:r>
                     </a:p>
                   </a:txBody>
@@ -14288,7 +14171,7 @@
                           </a:solidFill>
                           <a:latin typeface="Arial"/>
                         </a:rPr>
-                        <a:t>D0 / D1</a:t>
+                        <a:t>Average / weakest word</a:t>
                       </a:r>
                     </a:p>
                   </a:txBody>
@@ -14311,7 +14194,7 @@
                           </a:solidFill>
                           <a:latin typeface="Arial"/>
                         </a:rPr>
-                        <a:t>− mean / − min token log-prob of the answer</a:t>
+                        <a:t>the model's average, or lowest, confidence across the answer</a:t>
                       </a:r>
                     </a:p>
                   </a:txBody>
@@ -14359,7 +14242,7 @@
                           </a:solidFill>
                           <a:latin typeface="Arial"/>
                         </a:rPr>
-                        <a:t>D2 / D3</a:t>
+                        <a:t>Ours (DA1)</a:t>
                       </a:r>
                     </a:p>
                   </a:txBody>
@@ -14382,7 +14265,7 @@
                           </a:solidFill>
                           <a:latin typeface="Arial"/>
                         </a:rPr>
-                        <a:t>logistic regression on 3 / 17 token features (trained on dev)</a:t>
+                        <a:t>a small trained model combining 3 (or 17) confidence measures</a:t>
                       </a:r>
                     </a:p>
                   </a:txBody>
@@ -14430,7 +14313,7 @@
                           </a:solidFill>
                           <a:latin typeface="Arial"/>
                         </a:rPr>
-                        <a:t>D4 / D5</a:t>
+                        <a:t>Self-consistency</a:t>
                       </a:r>
                     </a:p>
                   </a:txBody>
@@ -14453,7 +14336,7 @@
                           </a:solidFill>
                           <a:latin typeface="Arial"/>
                         </a:rPr>
-                        <a:t>self-consistency over 5 samples (cosine similarity)</a:t>
+                        <a:t>ask 5 more times; do the answers agree?</a:t>
                       </a:r>
                     </a:p>
                   </a:txBody>
@@ -14501,7 +14384,7 @@
                           </a:solidFill>
                           <a:latin typeface="Arial"/>
                         </a:rPr>
-                        <a:t>D6</a:t>
+                        <a:t>Self-check</a:t>
                       </a:r>
                     </a:p>
                   </a:txBody>
@@ -14524,7 +14407,7 @@
                           </a:solidFill>
                           <a:latin typeface="Arial"/>
                         </a:rPr>
-                        <a:t>P(True): the model judges its own answer</a:t>
+                        <a:t>ask the model: “Is this answer true?”</a:t>
                       </a:r>
                     </a:p>
                   </a:txBody>
@@ -14572,7 +14455,7 @@
                           </a:solidFill>
                           <a:latin typeface="Arial"/>
                         </a:rPr>
-                        <a:t>D7 – D9</a:t>
+                        <a:t>Meaning check</a:t>
                       </a:r>
                     </a:p>
                   </a:txBody>
@@ -14595,7 +14478,7 @@
                           </a:solidFill>
                           <a:latin typeface="Arial"/>
                         </a:rPr>
-                        <a:t>semantic entropy over 5 samples (NLI entailment)</a:t>
+                        <a:t>ask 5 more times; do the answers mean the same thing?</a:t>
                       </a:r>
                     </a:p>
                   </a:txBody>
@@ -14618,7 +14501,7 @@
                           </a:solidFill>
                           <a:latin typeface="Arial"/>
                         </a:rPr>
-                        <a:t>6 + NLI</a:t>
+                        <a:t>6</a:t>
                       </a:r>
                     </a:p>
                   </a:txBody>
@@ -14685,7 +14568,7 @@
                 </a:solidFill>
                 <a:latin typeface="Arial"/>
               </a:rPr>
-              <a:t>Result 1: a weak signal, and none on TruthfulQA</a:t>
+              <a:t>Result 1: it catches mistakes on facts and science</a:t>
             </a:r>
           </a:p>
         </p:txBody>
@@ -14738,7 +14621,7 @@
         <p:spPr>
           <a:xfrm>
             <a:off x="1325880" y="1325880"/>
-            <a:ext cx="5120640" cy="4709160"/>
+            <a:ext cx="5394960" cy="4480560"/>
           </a:xfrm>
           <a:prstGeom prst="roundRect">
             <a:avLst>
@@ -14777,7 +14660,7 @@
       </p:sp>
       <p:pic>
         <p:nvPicPr>
-          <p:cNvPr id="5" name="Picture 4" descr="fig_v2_auroc.png"/>
+          <p:cNvPr id="5" name="Picture 4" descr="fig_detection_scores.png"/>
           <p:cNvPicPr>
             <a:picLocks noChangeAspect="1"/>
           </p:cNvPicPr>
@@ -14791,8 +14674,8 @@
         </p:blipFill>
         <p:spPr>
           <a:xfrm>
-            <a:off x="1435608" y="1579952"/>
-            <a:ext cx="4901183" cy="4201014"/>
+            <a:off x="1435608" y="1706213"/>
+            <a:ext cx="5175504" cy="3719893"/>
           </a:xfrm>
           <a:prstGeom prst="rect">
             <a:avLst/>
@@ -14807,8 +14690,8 @@
         </p:nvSpPr>
         <p:spPr>
           <a:xfrm>
-            <a:off x="6766560" y="1371600"/>
-            <a:ext cx="4206240" cy="685800"/>
+            <a:off x="6995160" y="1371600"/>
+            <a:ext cx="4023360" cy="685800"/>
           </a:xfrm>
           <a:prstGeom prst="rect">
             <a:avLst/>
@@ -14833,7 +14716,7 @@
                 </a:solidFill>
                 <a:latin typeface="Arial"/>
               </a:rPr>
-              <a:t>0.66–0.70</a:t>
+              <a:t>up to 0.81</a:t>
             </a:r>
           </a:p>
         </p:txBody>
@@ -14846,8 +14729,8 @@
         </p:nvSpPr>
         <p:spPr>
           <a:xfrm>
-            <a:off x="6766560" y="2029967"/>
-            <a:ext cx="4206240" cy="731520"/>
+            <a:off x="6995160" y="2029967"/>
+            <a:ext cx="4023360" cy="731520"/>
           </a:xfrm>
           <a:prstGeom prst="rect">
             <a:avLst/>
@@ -14872,7 +14755,7 @@
                 </a:solidFill>
                 <a:latin typeface="Arial"/>
               </a:rPr>
-              <a:t>SciQ: mean log-prob detects errors weakly, for all three models</a:t>
+              <a:t>on trivia questions (0.70–0.81 across the 3 models)</a:t>
             </a:r>
           </a:p>
         </p:txBody>
@@ -14885,8 +14768,86 @@
         </p:nvSpPr>
         <p:spPr>
           <a:xfrm>
-            <a:off x="6766560" y="2697480"/>
-            <a:ext cx="4206240" cy="685800"/>
+            <a:off x="6995160" y="2697480"/>
+            <a:ext cx="4023360" cy="685800"/>
+          </a:xfrm>
+          <a:prstGeom prst="rect">
+            <a:avLst/>
+          </a:prstGeom>
+          <a:noFill/>
+        </p:spPr>
+        <p:txBody>
+          <a:bodyPr wrap="square" anchor="t" lIns="45720" rIns="45720">
+            <a:spAutoFit/>
+          </a:bodyPr>
+          <a:lstStyle/>
+          <a:p>
+            <a:pPr algn="l">
+              <a:spcAft>
+                <a:spcPts val="600"/>
+              </a:spcAft>
+            </a:pPr>
+            <a:r>
+              <a:rPr sz="3400" b="1" i="0">
+                <a:solidFill>
+                  <a:srgbClr val="A6D97E"/>
+                </a:solidFill>
+                <a:latin typeface="Arial"/>
+              </a:rPr>
+              <a:t>0.68–0.73</a:t>
+            </a:r>
+          </a:p>
+        </p:txBody>
+      </p:sp>
+      <p:sp>
+        <p:nvSpPr>
+          <p:cNvPr id="9" name="TextBox 8"/>
+          <p:cNvSpPr txBox="1"/>
+          <p:nvPr/>
+        </p:nvSpPr>
+        <p:spPr>
+          <a:xfrm>
+            <a:off x="6995160" y="3355848"/>
+            <a:ext cx="4023360" cy="731520"/>
+          </a:xfrm>
+          <a:prstGeom prst="rect">
+            <a:avLst/>
+          </a:prstGeom>
+          <a:noFill/>
+        </p:spPr>
+        <p:txBody>
+          <a:bodyPr wrap="square" anchor="t" lIns="45720" rIns="45720">
+            <a:spAutoFit/>
+          </a:bodyPr>
+          <a:lstStyle/>
+          <a:p>
+            <a:pPr algn="l">
+              <a:spcAft>
+                <a:spcPts val="600"/>
+              </a:spcAft>
+            </a:pPr>
+            <a:r>
+              <a:rPr sz="1300" b="0" i="0">
+                <a:solidFill>
+                  <a:srgbClr val="C2CFC5"/>
+                </a:solidFill>
+                <a:latin typeface="Arial"/>
+              </a:rPr>
+              <a:t>on school science, consistent across all 3 models</a:t>
+            </a:r>
+          </a:p>
+        </p:txBody>
+      </p:sp>
+      <p:sp>
+        <p:nvSpPr>
+          <p:cNvPr id="10" name="TextBox 9"/>
+          <p:cNvSpPr txBox="1"/>
+          <p:nvPr/>
+        </p:nvSpPr>
+        <p:spPr>
+          <a:xfrm>
+            <a:off x="6995160" y="4023360"/>
+            <a:ext cx="4023360" cy="685800"/>
           </a:xfrm>
           <a:prstGeom prst="rect">
             <a:avLst/>
@@ -14911,21 +14872,21 @@
                 </a:solidFill>
                 <a:latin typeface="Arial"/>
               </a:rPr>
-              <a:t>0.47 · 0.50</a:t>
-            </a:r>
-          </a:p>
-        </p:txBody>
-      </p:sp>
-      <p:sp>
-        <p:nvSpPr>
-          <p:cNvPr id="9" name="TextBox 8"/>
+              <a:t>0.60 · 0.61</a:t>
+            </a:r>
+          </a:p>
+        </p:txBody>
+      </p:sp>
+      <p:sp>
+        <p:nvSpPr>
+          <p:cNvPr id="11" name="TextBox 10"/>
           <p:cNvSpPr txBox="1"/>
           <p:nvPr/>
         </p:nvSpPr>
         <p:spPr>
           <a:xfrm>
-            <a:off x="6766560" y="3355848"/>
-            <a:ext cx="4206240" cy="731520"/>
+            <a:off x="6995160" y="4681728"/>
+            <a:ext cx="4023360" cy="731520"/>
           </a:xfrm>
           <a:prstGeom prst="rect">
             <a:avLst/>
@@ -14950,85 +14911,7 @@
                 </a:solidFill>
                 <a:latin typeface="Arial"/>
               </a:rPr>
-              <a:t>TruthfulQA, Qwen and SmolLM2: chance level (0.5)</a:t>
-            </a:r>
-          </a:p>
-        </p:txBody>
-      </p:sp>
-      <p:sp>
-        <p:nvSpPr>
-          <p:cNvPr id="10" name="TextBox 9"/>
-          <p:cNvSpPr txBox="1"/>
-          <p:nvPr/>
-        </p:nvSpPr>
-        <p:spPr>
-          <a:xfrm>
-            <a:off x="6766560" y="4023360"/>
-            <a:ext cx="4206240" cy="685800"/>
-          </a:xfrm>
-          <a:prstGeom prst="rect">
-            <a:avLst/>
-          </a:prstGeom>
-          <a:noFill/>
-        </p:spPr>
-        <p:txBody>
-          <a:bodyPr wrap="square" anchor="t" lIns="45720" rIns="45720">
-            <a:spAutoFit/>
-          </a:bodyPr>
-          <a:lstStyle/>
-          <a:p>
-            <a:pPr algn="l">
-              <a:spcAft>
-                <a:spcPts val="600"/>
-              </a:spcAft>
-            </a:pPr>
-            <a:r>
-              <a:rPr sz="3400" b="1" i="0">
-                <a:solidFill>
-                  <a:srgbClr val="A6D97E"/>
-                </a:solidFill>
-                <a:latin typeface="Arial"/>
-              </a:rPr>
-              <a:t>&lt; 0.80</a:t>
-            </a:r>
-          </a:p>
-        </p:txBody>
-      </p:sp>
-      <p:sp>
-        <p:nvSpPr>
-          <p:cNvPr id="11" name="TextBox 10"/>
-          <p:cNvSpPr txBox="1"/>
-          <p:nvPr/>
-        </p:nvSpPr>
-        <p:spPr>
-          <a:xfrm>
-            <a:off x="6766560" y="4681728"/>
-            <a:ext cx="4206240" cy="731520"/>
-          </a:xfrm>
-          <a:prstGeom prst="rect">
-            <a:avLst/>
-          </a:prstGeom>
-          <a:noFill/>
-        </p:spPr>
-        <p:txBody>
-          <a:bodyPr wrap="square" anchor="t" lIns="45720" rIns="45720">
-            <a:spAutoFit/>
-          </a:bodyPr>
-          <a:lstStyle/>
-          <a:p>
-            <a:pPr algn="l">
-              <a:spcAft>
-                <a:spcPts val="600"/>
-              </a:spcAft>
-            </a:pPr>
-            <a:r>
-              <a:rPr sz="1300" b="0" i="0">
-                <a:solidFill>
-                  <a:srgbClr val="C2CFC5"/>
-                </a:solidFill>
-                <a:latin typeface="Arial"/>
-              </a:rPr>
-              <a:t>every detector on TruthfulQA and SciQ; best is the 3-feature model (0.60–0.73)</a:t>
+              <a:t>on misconception traps for Qwen and SmolLM2: the puzzle we solved next</a:t>
             </a:r>
           </a:p>
         </p:txBody>
@@ -15085,7 +14968,7 @@
                 </a:solidFill>
                 <a:latin typeface="Arial"/>
               </a:rPr>
-              <a:t>Answer to DA1: one call is as good as six</a:t>
+              <a:t>Result 2: one call beats six</a:t>
             </a:r>
           </a:p>
         </p:txBody>
@@ -15139,7 +15022,7 @@
         </p:nvGraphicFramePr>
         <p:xfrm>
           <a:off x="1325880" y="1463040"/>
-          <a:ext cx="9710928" cy="3017520"/>
+          <a:ext cx="9692640" cy="3017520"/>
         </p:xfrm>
         <a:graphic>
           <a:graphicData uri="http://schemas.openxmlformats.org/drawingml/2006/table">
@@ -15148,14 +15031,14 @@
                 <a:tableStyleId>{5940675A-B579-460E-94D1-54222C63F5DA}</a:tableStyleId>
               </a:tblPr>
               <a:tblGrid>
-                <a:gridCol w="2286000"/>
+                <a:gridCol w="2651760"/>
                 <a:gridCol w="731520"/>
-                <a:gridCol w="1115568"/>
-                <a:gridCol w="1115568"/>
-                <a:gridCol w="1115568"/>
-                <a:gridCol w="1115568"/>
-                <a:gridCol w="1115568"/>
-                <a:gridCol w="1115568"/>
+                <a:gridCol w="1051560"/>
+                <a:gridCol w="1051560"/>
+                <a:gridCol w="1051560"/>
+                <a:gridCol w="1051560"/>
+                <a:gridCol w="1051560"/>
+                <a:gridCol w="1051560"/>
               </a:tblGrid>
               <a:tr h="502920">
                 <a:tc>
@@ -15217,7 +15100,7 @@
                           </a:solidFill>
                           <a:latin typeface="Arial"/>
                         </a:rPr>
-                        <a:t>TQA Qwen</a:t>
+                        <a:t>Trap Qwen</a:t>
                       </a:r>
                     </a:p>
                   </a:txBody>
@@ -15240,7 +15123,7 @@
                           </a:solidFill>
                           <a:latin typeface="Arial"/>
                         </a:rPr>
-                        <a:t>TQA Llama</a:t>
+                        <a:t>Trap Llama</a:t>
                       </a:r>
                     </a:p>
                   </a:txBody>
@@ -15263,7 +15146,7 @@
                           </a:solidFill>
                           <a:latin typeface="Arial"/>
                         </a:rPr>
-                        <a:t>TQA Smol</a:t>
+                        <a:t>Trap Smol</a:t>
                       </a:r>
                     </a:p>
                   </a:txBody>
@@ -15286,7 +15169,7 @@
                           </a:solidFill>
                           <a:latin typeface="Arial"/>
                         </a:rPr>
-                        <a:t>SciQ Qwen</a:t>
+                        <a:t>Sci Qwen</a:t>
                       </a:r>
                     </a:p>
                   </a:txBody>
@@ -15309,7 +15192,7 @@
                           </a:solidFill>
                           <a:latin typeface="Arial"/>
                         </a:rPr>
-                        <a:t>SciQ Llama</a:t>
+                        <a:t>Sci Llama</a:t>
                       </a:r>
                     </a:p>
                   </a:txBody>
@@ -15332,7 +15215,7 @@
                           </a:solidFill>
                           <a:latin typeface="Arial"/>
                         </a:rPr>
-                        <a:t>SciQ Smol</a:t>
+                        <a:t>Sci Smol</a:t>
                       </a:r>
                     </a:p>
                   </a:txBody>
@@ -15357,7 +15240,7 @@
                           </a:solidFill>
                           <a:latin typeface="Arial"/>
                         </a:rPr>
-                        <a:t>D0 mean log-prob</a:t>
+                        <a:t>Average word confidence</a:t>
                       </a:r>
                     </a:p>
                   </a:txBody>
@@ -15403,7 +15286,7 @@
                           </a:solidFill>
                           <a:latin typeface="Arial"/>
                         </a:rPr>
-                        <a:t>0.466</a:t>
+                        <a:t>0.47</a:t>
                       </a:r>
                     </a:p>
                   </a:txBody>
@@ -15426,7 +15309,7 @@
                           </a:solidFill>
                           <a:latin typeface="Arial"/>
                         </a:rPr>
-                        <a:t>0.653</a:t>
+                        <a:t>0.65</a:t>
                       </a:r>
                     </a:p>
                   </a:txBody>
@@ -15449,7 +15332,7 @@
                           </a:solidFill>
                           <a:latin typeface="Arial"/>
                         </a:rPr>
-                        <a:t>0.500</a:t>
+                        <a:t>0.50</a:t>
                       </a:r>
                     </a:p>
                   </a:txBody>
@@ -15472,7 +15355,7 @@
                           </a:solidFill>
                           <a:latin typeface="Arial"/>
                         </a:rPr>
-                        <a:t>0.688</a:t>
+                        <a:t>0.69</a:t>
                       </a:r>
                     </a:p>
                   </a:txBody>
@@ -15495,7 +15378,7 @@
                           </a:solidFill>
                           <a:latin typeface="Arial"/>
                         </a:rPr>
-                        <a:t>0.658</a:t>
+                        <a:t>0.66</a:t>
                       </a:r>
                     </a:p>
                   </a:txBody>
@@ -15518,7 +15401,7 @@
                           </a:solidFill>
                           <a:latin typeface="Arial"/>
                         </a:rPr>
-                        <a:t>0.702</a:t>
+                        <a:t>0.70</a:t>
                       </a:r>
                     </a:p>
                   </a:txBody>
@@ -15543,7 +15426,7 @@
                           </a:solidFill>
                           <a:latin typeface="Arial"/>
                         </a:rPr>
-                        <a:t>D2 3-feature LR</a:t>
+                        <a:t>Ours (DA1, 3 measures)</a:t>
                       </a:r>
                     </a:p>
                   </a:txBody>
@@ -15589,7 +15472,7 @@
                           </a:solidFill>
                           <a:latin typeface="Arial"/>
                         </a:rPr>
-                        <a:t>0.600</a:t>
+                        <a:t>0.60</a:t>
                       </a:r>
                     </a:p>
                   </a:txBody>
@@ -15612,7 +15495,7 @@
                           </a:solidFill>
                           <a:latin typeface="Arial"/>
                         </a:rPr>
-                        <a:t>0.726</a:t>
+                        <a:t>0.73</a:t>
                       </a:r>
                     </a:p>
                   </a:txBody>
@@ -15635,7 +15518,7 @@
                           </a:solidFill>
                           <a:latin typeface="Arial"/>
                         </a:rPr>
-                        <a:t>0.611</a:t>
+                        <a:t>0.61</a:t>
                       </a:r>
                     </a:p>
                   </a:txBody>
@@ -15658,7 +15541,7 @@
                           </a:solidFill>
                           <a:latin typeface="Arial"/>
                         </a:rPr>
-                        <a:t>0.728</a:t>
+                        <a:t>0.73</a:t>
                       </a:r>
                     </a:p>
                   </a:txBody>
@@ -15681,7 +15564,7 @@
                           </a:solidFill>
                           <a:latin typeface="Arial"/>
                         </a:rPr>
-                        <a:t>0.685</a:t>
+                        <a:t>0.68</a:t>
                       </a:r>
                     </a:p>
                   </a:txBody>
@@ -15704,7 +15587,7 @@
                           </a:solidFill>
                           <a:latin typeface="Arial"/>
                         </a:rPr>
-                        <a:t>0.727</a:t>
+                        <a:t>0.73</a:t>
                       </a:r>
                     </a:p>
                   </a:txBody>
@@ -15729,7 +15612,7 @@
                           </a:solidFill>
                           <a:latin typeface="Arial"/>
                         </a:rPr>
-                        <a:t>D4 self-consistency</a:t>
+                        <a:t>Self-consistency</a:t>
                       </a:r>
                     </a:p>
                   </a:txBody>
@@ -15775,7 +15658,7 @@
                           </a:solidFill>
                           <a:latin typeface="Arial"/>
                         </a:rPr>
-                        <a:t>0.517</a:t>
+                        <a:t>0.52</a:t>
                       </a:r>
                     </a:p>
                   </a:txBody>
@@ -15798,7 +15681,7 @@
                           </a:solidFill>
                           <a:latin typeface="Arial"/>
                         </a:rPr>
-                        <a:t>0.511</a:t>
+                        <a:t>0.51</a:t>
                       </a:r>
                     </a:p>
                   </a:txBody>
@@ -15821,7 +15704,7 @@
                           </a:solidFill>
                           <a:latin typeface="Arial"/>
                         </a:rPr>
-                        <a:t>0.502</a:t>
+                        <a:t>0.50</a:t>
                       </a:r>
                     </a:p>
                   </a:txBody>
@@ -15844,7 +15727,7 @@
                           </a:solidFill>
                           <a:latin typeface="Arial"/>
                         </a:rPr>
-                        <a:t>0.566</a:t>
+                        <a:t>0.57</a:t>
                       </a:r>
                     </a:p>
                   </a:txBody>
@@ -15867,7 +15750,7 @@
                           </a:solidFill>
                           <a:latin typeface="Arial"/>
                         </a:rPr>
-                        <a:t>0.603</a:t>
+                        <a:t>0.60</a:t>
                       </a:r>
                     </a:p>
                   </a:txBody>
@@ -15890,7 +15773,7 @@
                           </a:solidFill>
                           <a:latin typeface="Arial"/>
                         </a:rPr>
-                        <a:t>0.553</a:t>
+                        <a:t>0.55</a:t>
                       </a:r>
                     </a:p>
                   </a:txBody>
@@ -15915,7 +15798,7 @@
                           </a:solidFill>
                           <a:latin typeface="Arial"/>
                         </a:rPr>
-                        <a:t>D6 P(True)</a:t>
+                        <a:t>Self-check “is it true?”</a:t>
                       </a:r>
                     </a:p>
                   </a:txBody>
@@ -15961,7 +15844,7 @@
                           </a:solidFill>
                           <a:latin typeface="Arial"/>
                         </a:rPr>
-                        <a:t>0.426</a:t>
+                        <a:t>0.43</a:t>
                       </a:r>
                     </a:p>
                   </a:txBody>
@@ -15984,7 +15867,7 @@
                           </a:solidFill>
                           <a:latin typeface="Arial"/>
                         </a:rPr>
-                        <a:t>0.381</a:t>
+                        <a:t>0.38</a:t>
                       </a:r>
                     </a:p>
                   </a:txBody>
@@ -16007,7 +15890,7 @@
                           </a:solidFill>
                           <a:latin typeface="Arial"/>
                         </a:rPr>
-                        <a:t>0.477</a:t>
+                        <a:t>0.48</a:t>
                       </a:r>
                     </a:p>
                   </a:txBody>
@@ -16030,7 +15913,7 @@
                           </a:solidFill>
                           <a:latin typeface="Arial"/>
                         </a:rPr>
-                        <a:t>0.678</a:t>
+                        <a:t>0.68</a:t>
                       </a:r>
                     </a:p>
                   </a:txBody>
@@ -16053,7 +15936,7 @@
                           </a:solidFill>
                           <a:latin typeface="Arial"/>
                         </a:rPr>
-                        <a:t>0.573</a:t>
+                        <a:t>0.57</a:t>
                       </a:r>
                     </a:p>
                   </a:txBody>
@@ -16076,7 +15959,7 @@
                           </a:solidFill>
                           <a:latin typeface="Arial"/>
                         </a:rPr>
-                        <a:t>0.676</a:t>
+                        <a:t>0.68</a:t>
                       </a:r>
                     </a:p>
                   </a:txBody>
@@ -16101,7 +15984,7 @@
                           </a:solidFill>
                           <a:latin typeface="Arial"/>
                         </a:rPr>
-                        <a:t>D7 semantic entropy</a:t>
+                        <a:t>Meaning check</a:t>
                       </a:r>
                     </a:p>
                   </a:txBody>
@@ -16147,7 +16030,7 @@
                           </a:solidFill>
                           <a:latin typeface="Arial"/>
                         </a:rPr>
-                        <a:t>0.492</a:t>
+                        <a:t>0.49</a:t>
                       </a:r>
                     </a:p>
                   </a:txBody>
@@ -16170,7 +16053,7 @@
                           </a:solidFill>
                           <a:latin typeface="Arial"/>
                         </a:rPr>
-                        <a:t>0.567</a:t>
+                        <a:t>0.57</a:t>
                       </a:r>
                     </a:p>
                   </a:txBody>
@@ -16193,7 +16076,7 @@
                           </a:solidFill>
                           <a:latin typeface="Arial"/>
                         </a:rPr>
-                        <a:t>0.515</a:t>
+                        <a:t>0.51</a:t>
                       </a:r>
                     </a:p>
                   </a:txBody>
@@ -16216,7 +16099,7 @@
                           </a:solidFill>
                           <a:latin typeface="Arial"/>
                         </a:rPr>
-                        <a:t>0.714</a:t>
+                        <a:t>0.71</a:t>
                       </a:r>
                     </a:p>
                   </a:txBody>
@@ -16239,7 +16122,7 @@
                           </a:solidFill>
                           <a:latin typeface="Arial"/>
                         </a:rPr>
-                        <a:t>0.624</a:t>
+                        <a:t>0.62</a:t>
                       </a:r>
                     </a:p>
                   </a:txBody>
@@ -16262,7 +16145,7 @@
                           </a:solidFill>
                           <a:latin typeface="Arial"/>
                         </a:rPr>
-                        <a:t>0.686</a:t>
+                        <a:t>0.69</a:t>
                       </a:r>
                     </a:p>
                   </a:txBody>
@@ -16279,14 +16162,60 @@
       </p:graphicFrame>
       <p:sp>
         <p:nvSpPr>
-          <p:cNvPr id="5" name="TextBox 4"/>
+          <p:cNvPr id="5" name="Rounded Rectangle 4"/>
+          <p:cNvSpPr/>
+          <p:nvPr/>
+        </p:nvSpPr>
+        <p:spPr>
+          <a:xfrm>
+            <a:off x="1325880" y="4617720"/>
+            <a:ext cx="9692640" cy="1005840"/>
+          </a:xfrm>
+          <a:prstGeom prst="roundRect">
+            <a:avLst>
+              <a:gd name="adj" fmla="val 8000"/>
+            </a:avLst>
+          </a:prstGeom>
+          <a:solidFill>
+            <a:srgbClr val="A6D97E"/>
+          </a:solidFill>
+          <a:ln>
+            <a:noFill/>
+          </a:ln>
+          <a:effectLst/>
+        </p:spPr>
+        <p:style>
+          <a:lnRef idx="1">
+            <a:schemeClr val="accent1"/>
+          </a:lnRef>
+          <a:fillRef idx="3">
+            <a:schemeClr val="accent1"/>
+          </a:fillRef>
+          <a:effectRef idx="2">
+            <a:schemeClr val="accent1"/>
+          </a:effectRef>
+          <a:fontRef idx="minor">
+            <a:schemeClr val="lt1"/>
+          </a:fontRef>
+        </p:style>
+        <p:txBody>
+          <a:bodyPr rtlCol="0" anchor="ctr"/>
+          <a:lstStyle/>
+          <a:p>
+            <a:pPr algn="ctr"/>
+          </a:p>
+        </p:txBody>
+      </p:sp>
+      <p:sp>
+        <p:nvSpPr>
+          <p:cNvPr id="6" name="TextBox 5"/>
           <p:cNvSpPr txBox="1"/>
           <p:nvPr/>
         </p:nvSpPr>
         <p:spPr>
           <a:xfrm>
-            <a:off x="1325880" y="4617720"/>
-            <a:ext cx="9692640" cy="1280160"/>
+            <a:off x="1600200" y="4663440"/>
+            <a:ext cx="9144000" cy="914400"/>
           </a:xfrm>
           <a:prstGeom prst="rect">
             <a:avLst/>
@@ -16294,7 +16223,7 @@
           <a:noFill/>
         </p:spPr>
         <p:txBody>
-          <a:bodyPr wrap="square" anchor="t" lIns="45720" rIns="45720">
+          <a:bodyPr wrap="square" anchor="ctr" lIns="45720" rIns="45720">
             <a:spAutoFit/>
           </a:bodyPr>
           <a:lstStyle/>
@@ -16305,22 +16234,31 @@
               </a:spcAft>
             </a:pPr>
             <a:r>
-              <a:rPr sz="1400" b="1" i="0">
+              <a:rPr sz="1600" b="1" i="0">
                 <a:solidFill>
-                  <a:srgbClr val="F6B26B"/>
+                  <a:srgbClr val="1C2620"/>
                 </a:solidFill>
                 <a:latin typeface="Arial"/>
               </a:rPr>
-              <a:t>Amber = best in column. </a:t>
-            </a:r>
-            <a:r>
-              <a:rPr sz="1400" b="0" i="0">
+              <a:t>Our 1-call detector beat every multi-call method in </a:t>
+            </a:r>
+            <a:r>
+              <a:rPr sz="1600" b="1" i="0">
                 <a:solidFill>
-                  <a:srgbClr val="C2CFC5"/>
+                  <a:srgbClr val="1C2620"/>
                 </a:solidFill>
                 <a:latin typeface="Arial"/>
               </a:rPr>
-              <a:t>AUROC on the held-out confirm split; 0.5 = chance. Values below 0.5 mean the detector rates wrong answers as safer than right ones (P(True) on TruthfulQA).</a:t>
+              <a:t>6 of 6</a:t>
+            </a:r>
+            <a:r>
+              <a:rPr sz="1600" b="0" i="0">
+                <a:solidFill>
+                  <a:srgbClr val="1C2620"/>
+                </a:solidFill>
+                <a:latin typeface="Arial"/>
+              </a:rPr>
+              <a:t> settings, at 1/6 of the cost. Orange = best in column; 0.5 = guessing.</a:t>
             </a:r>
           </a:p>
         </p:txBody>
@@ -16377,7 +16315,7 @@
                 </a:solidFill>
                 <a:latin typeface="Arial"/>
               </a:rPr>
-              <a:t>Result 2: the blind spot is learned misconceptions</a:t>
+              <a:t>Result 3: the blind spot is learned misconceptions</a:t>
             </a:r>
           </a:p>
         </p:txBody>
@@ -16521,11 +16459,11 @@
             <a:r>
               <a:rPr sz="3400" b="1" i="0">
                 <a:solidFill>
-                  <a:srgbClr val="F6B26B"/>
+                  <a:srgbClr val="A6D97E"/>
                 </a:solidFill>
                 <a:latin typeface="Arial"/>
               </a:rPr>
-              <a:t>0.42 · 0.45</a:t>
+              <a:t>0.58–0.71</a:t>
             </a:r>
           </a:p>
         </p:txBody>
@@ -16564,7 +16502,7 @@
                 </a:solidFill>
                 <a:latin typeface="Arial"/>
               </a:rPr>
-              <a:t>misconception errors vs correct (Qwen, SmolLM2): at or below chance</a:t>
+              <a:t>made-up facts (wrong names, numbers): caught by the model's confidence</a:t>
             </a:r>
           </a:p>
         </p:txBody>
@@ -16599,11 +16537,11 @@
             <a:r>
               <a:rPr sz="3400" b="1" i="0">
                 <a:solidFill>
-                  <a:srgbClr val="A6D97E"/>
+                  <a:srgbClr val="F6B26B"/>
                 </a:solidFill>
                 <a:latin typeface="Arial"/>
               </a:rPr>
-              <a:t>0.58 · 0.63</a:t>
+              <a:t>0.42 · 0.45</a:t>
             </a:r>
           </a:p>
         </p:txBody>
@@ -16642,7 +16580,7 @@
                 </a:solidFill>
                 <a:latin typeface="Arial"/>
               </a:rPr>
-              <a:t>other errors vs correct: detectable</a:t>
+              <a:t>repeated misconceptions (Qwen, SmolLM2): as confident as correct answers</a:t>
             </a:r>
           </a:p>
         </p:txBody>
@@ -16675,13 +16613,13 @@
               </a:spcAft>
             </a:pPr>
             <a:r>
-              <a:rPr sz="3400" b="1" i="0">
+              <a:rPr sz="2800" b="1" i="0">
                 <a:solidFill>
                   <a:srgbClr val="F4F7F2"/>
                 </a:solidFill>
                 <a:latin typeface="Arial"/>
               </a:rPr>
-              <a:t>−0.16 · −0.18</a:t>
+              <a:t>All methods</a:t>
             </a:r>
           </a:p>
         </p:txBody>
@@ -16720,7 +16658,7 @@
                 </a:solidFill>
                 <a:latin typeface="Arial"/>
               </a:rPr>
-              <a:t>preregistered gap, Holm p = 0.005 and 0.003</a:t>
+              <a:t>share this blind spot: self-check and meaning check too</a:t>
             </a:r>
           </a:p>
         </p:txBody>
@@ -16759,7 +16697,7 @@
                 </a:solidFill>
                 <a:latin typeface="Arial"/>
               </a:rPr>
-              <a:t>Hollow = misconception errors, filled = other errors, for four signal families.</a:t>
+              <a:t>Hollow = misconception mistakes, filled = other mistakes, for four kinds of detector. Left of 0.5 = invisible.</a:t>
             </a:r>
           </a:p>
         </p:txBody>
@@ -16816,7 +16754,7 @@
                 </a:solidFill>
                 <a:latin typeface="Arial"/>
               </a:rPr>
-              <a:t>What a confident hallucination looks like</a:t>
+              <a:t>What a confident mistake looks like</a:t>
             </a:r>
           </a:p>
         </p:txBody>
@@ -16870,7 +16808,7 @@
         </p:nvGraphicFramePr>
         <p:xfrm>
           <a:off x="1325880" y="1463040"/>
-          <a:ext cx="9692640" cy="3291840"/>
+          <a:ext cx="9692639" cy="3291840"/>
         </p:xfrm>
         <a:graphic>
           <a:graphicData uri="http://schemas.openxmlformats.org/drawingml/2006/table">
@@ -16879,10 +16817,10 @@
                 <a:tableStyleId>{5940675A-B579-460E-94D1-54222C63F5DA}</a:tableStyleId>
               </a:tblPr>
               <a:tblGrid>
-                <a:gridCol w="4023360"/>
+                <a:gridCol w="3749039"/>
                 <a:gridCol w="2148840"/>
-                <a:gridCol w="1600200"/>
-                <a:gridCol w="1920240"/>
+                <a:gridCol w="1417320"/>
+                <a:gridCol w="2377440"/>
               </a:tblGrid>
               <a:tr h="658368">
                 <a:tc>
@@ -16898,7 +16836,7 @@
                           </a:solidFill>
                           <a:latin typeface="Arial"/>
                         </a:rPr>
-                        <a:t>Question (TruthfulQA, held out)</a:t>
+                        <a:t>Question</a:t>
                       </a:r>
                     </a:p>
                   </a:txBody>
@@ -16967,7 +16905,7 @@
                           </a:solidFill>
                           <a:latin typeface="Arial"/>
                         </a:rPr>
-                        <a:t>Confidence pct Q / L / S</a:t>
+                        <a:t>More confident than … % of its answers (Q / L / S)</a:t>
                       </a:r>
                     </a:p>
                   </a:txBody>
@@ -17132,7 +17070,7 @@
                           </a:solidFill>
                           <a:latin typeface="Arial"/>
                         </a:rPr>
-                        <a:t>not an acronym</a:t>
+                        <a:t>nothing</a:t>
                       </a:r>
                     </a:p>
                   </a:txBody>
@@ -17392,7 +17330,7 @@
                 </a:solidFill>
                 <a:latin typeface="Arial"/>
               </a:rPr>
-              <a:t>Confidence percentile = rank of the answer's mean log-prob among the same model's 617 held-out answers (100 = most confident). 11 questions qualify; the four most confident are shown. Verbatim answers: analysis_v3/extensions.json.</a:t>
+              <a:t>11 test questions where all three models confidently repeat the same misconception; the four most confident are shown.</a:t>
             </a:r>
           </a:p>
         </p:txBody>

</xml_diff>